<commit_message>
Add per-task threshold finding and class-weighted retraining plan
- report.md and literature survey: document the per-task threshold sweep
  (Summary +4.4 F1, held-out and honest, no retrain needed) and add
  class-weighted retraining as the genuinely planned (not yet run) fix for
  Summary's 3% token-level class sparsity
- pptx: fixed a real bug where chart data labels were configured but never
  told to display (show_value was never set) across all 3 charts; replaced
  slide 16's global-only threshold callouts with a per-task table; updated
  slide 17's findings list; removed remaining em dashes left over from the
  original deck build (the earlier em-dash cleanup only covered the .md
  files, not the pptx)
</commit_message>
<xml_diff>
--- a/docs/LettuceDetect_Presentation_.pptx
+++ b/docs/LettuceDetect_Presentation_.pptx
@@ -168,11 +168,11 @@
               <a:lstStyle/>
               <a:p>
                 <a:pPr>
-                  <a:defRPr b="0" i="0" strike="noStrike" sz="1000" u="none">
+                  <a:defRPr b="1" i="0" strike="noStrike" sz="1000" u="none">
                     <a:solidFill>
                       <a:srgbClr val="1F2D2D"/>
                     </a:solidFill>
-                    <a:latin typeface="Arial"/>
+                    <a:latin typeface="Calibri"/>
                   </a:defRPr>
                 </a:pPr>
               </a:p>
@@ -354,11 +354,11 @@
             <a:lstStyle/>
             <a:p>
               <a:pPr>
-                <a:defRPr b="0" i="0" strike="noStrike" sz="1000" u="none">
+                <a:defRPr b="1" i="0" strike="noStrike" sz="1000" u="none">
                   <a:solidFill>
                     <a:srgbClr val="1F2D2D"/>
                   </a:solidFill>
-                  <a:latin typeface="Arial"/>
+                  <a:latin typeface="Calibri"/>
                 </a:defRPr>
               </a:pPr>
             </a:p>
@@ -626,7 +626,7 @@
               </a:p>
             </c:txPr>
             <c:showLegendKey val="0"/>
-            <c:showVal val="0"/>
+            <c:showVal val="1"/>
             <c:showCatName val="0"/>
             <c:showSerName val="0"/>
             <c:showPercent val="0"/>
@@ -696,6 +696,27 @@
             </c:numRef>
           </c:val>
         </c:ser>
+        <c:dLbls>
+          <c:numFmt sourceLinked="0"/>
+          <c:txPr>
+            <a:bodyPr/>
+            <a:lstStyle/>
+            <a:p>
+              <a:pPr>
+                <a:defRPr sz="1000" b="1">
+                  <a:latin typeface="Calibri"/>
+                </a:defRPr>
+              </a:pPr>
+            </a:p>
+          </c:txPr>
+          <c:showLegendKey val="0"/>
+          <c:showVal val="1"/>
+          <c:showCatName val="0"/>
+          <c:showSerName val="0"/>
+          <c:showPercent val="0"/>
+          <c:showBubbleSize val="0"/>
+          <c:showLeaderLines val="1"/>
+        </c:dLbls>
         <c:axId val="-2068027336"/>
         <c:axId val="-2113994440"/>
       </c:barChart>
@@ -834,7 +855,7 @@
               </a:p>
             </c:txPr>
             <c:showLegendKey val="0"/>
-            <c:showVal val="0"/>
+            <c:showVal val="1"/>
             <c:showCatName val="0"/>
             <c:showSerName val="0"/>
             <c:showPercent val="0"/>
@@ -916,7 +937,7 @@
               </a:p>
             </c:txPr>
             <c:showLegendKey val="0"/>
-            <c:showVal val="0"/>
+            <c:showVal val="1"/>
             <c:showCatName val="0"/>
             <c:showSerName val="0"/>
             <c:showPercent val="0"/>
@@ -998,7 +1019,7 @@
               </a:p>
             </c:txPr>
             <c:showLegendKey val="0"/>
-            <c:showVal val="0"/>
+            <c:showVal val="1"/>
             <c:showCatName val="0"/>
             <c:showSerName val="0"/>
             <c:showPercent val="0"/>
@@ -1041,6 +1062,27 @@
             </c:numRef>
           </c:val>
         </c:ser>
+        <c:dLbls>
+          <c:numFmt sourceLinked="0"/>
+          <c:txPr>
+            <a:bodyPr/>
+            <a:lstStyle/>
+            <a:p>
+              <a:pPr>
+                <a:defRPr sz="1000" b="1">
+                  <a:latin typeface="Calibri"/>
+                </a:defRPr>
+              </a:pPr>
+            </a:p>
+          </c:txPr>
+          <c:showLegendKey val="0"/>
+          <c:showVal val="1"/>
+          <c:showCatName val="0"/>
+          <c:showSerName val="0"/>
+          <c:showPercent val="0"/>
+          <c:showBubbleSize val="0"/>
+          <c:showLeaderLines val="1"/>
+        </c:dLbls>
         <c:axId val="-2068027336"/>
         <c:axId val="-2113994440"/>
       </c:barChart>
@@ -1189,6 +1231,27 @@
               </a:ln>
             </c:spPr>
           </c:marker>
+          <c:dLbls>
+            <c:numFmt sourceLinked="0"/>
+            <c:txPr>
+              <a:bodyPr/>
+              <a:lstStyle/>
+              <a:p>
+                <a:pPr>
+                  <a:defRPr sz="1000" b="1">
+                    <a:latin typeface="Calibri"/>
+                  </a:defRPr>
+                </a:pPr>
+              </a:p>
+            </c:txPr>
+            <c:showLegendKey val="0"/>
+            <c:showVal val="1"/>
+            <c:showCatName val="0"/>
+            <c:showSerName val="0"/>
+            <c:showPercent val="0"/>
+            <c:showBubbleSize val="0"/>
+            <c:showLeaderLines val="1"/>
+          </c:dLbls>
           <c:cat>
             <c:strRef>
               <c:f>Sheet1!$A$2:$A$20</c:f>
@@ -1356,6 +1419,27 @@
               </a:ln>
             </c:spPr>
           </c:marker>
+          <c:dLbls>
+            <c:numFmt sourceLinked="0"/>
+            <c:txPr>
+              <a:bodyPr/>
+              <a:lstStyle/>
+              <a:p>
+                <a:pPr>
+                  <a:defRPr sz="1000" b="1">
+                    <a:latin typeface="Calibri"/>
+                  </a:defRPr>
+                </a:pPr>
+              </a:p>
+            </c:txPr>
+            <c:showLegendKey val="0"/>
+            <c:showVal val="1"/>
+            <c:showCatName val="0"/>
+            <c:showSerName val="0"/>
+            <c:showPercent val="0"/>
+            <c:showBubbleSize val="0"/>
+            <c:showLeaderLines val="1"/>
+          </c:dLbls>
           <c:cat>
             <c:strRef>
               <c:f>Sheet1!$A$2:$A$20</c:f>
@@ -1489,6 +1573,27 @@
           </c:val>
           <c:smooth val="0"/>
         </c:ser>
+        <c:dLbls>
+          <c:numFmt sourceLinked="0"/>
+          <c:txPr>
+            <a:bodyPr/>
+            <a:lstStyle/>
+            <a:p>
+              <a:pPr>
+                <a:defRPr sz="1000" b="1">
+                  <a:latin typeface="Calibri"/>
+                </a:defRPr>
+              </a:pPr>
+            </a:p>
+          </c:txPr>
+          <c:showLegendKey val="0"/>
+          <c:showVal val="1"/>
+          <c:showCatName val="0"/>
+          <c:showSerName val="0"/>
+          <c:showPercent val="0"/>
+          <c:showBubbleSize val="0"/>
+          <c:showLeaderLines val="1"/>
+        </c:dLbls>
         <c:marker val="1"/>
         <c:smooth val="0"/>
         <c:axId val="2118791784"/>
@@ -3728,6 +3833,10 @@
           </a:solidFill>
           <a:ln/>
         </p:spPr>
+        <p:txBody>
+          <a:bodyPr/>
+          <a:p/>
+        </p:txBody>
       </p:sp>
       <p:sp>
         <p:nvSpPr>
@@ -3750,6 +3859,10 @@
           </a:solidFill>
           <a:ln/>
         </p:spPr>
+        <p:txBody>
+          <a:bodyPr/>
+          <a:p/>
+        </p:txBody>
       </p:sp>
       <p:sp>
         <p:nvSpPr>
@@ -3770,6 +3883,10 @@
           </a:solidFill>
           <a:ln/>
         </p:spPr>
+        <p:txBody>
+          <a:bodyPr/>
+          <a:p/>
+        </p:txBody>
       </p:sp>
       <p:pic>
         <p:nvPicPr>
@@ -3934,6 +4051,10 @@
             <a:prstDash val="solid"/>
           </a:ln>
         </p:spPr>
+        <p:txBody>
+          <a:bodyPr/>
+          <a:p/>
+        </p:txBody>
       </p:sp>
       <p:sp>
         <p:nvSpPr>
@@ -3968,7 +4089,7 @@
                 <a:ea typeface="Cambria" pitchFamily="34" charset="-122"/>
                 <a:cs typeface="Cambria" pitchFamily="34" charset="-120"/>
               </a:rPr>
-              <a:t>"Can we trust what a RAG system tells us — and can we trust</a:t>
+              <a:t>"Can we trust what a RAG system tells us, and can we trust</a:t>
             </a:r>
             <a:endParaRPr lang="en-US" sz="1600" dirty="0"/>
           </a:p>
@@ -4276,7 +4397,7 @@
                 <a:ea typeface="Calibri" pitchFamily="34" charset="-122"/>
                 <a:cs typeface="Calibri" pitchFamily="34" charset="-120"/>
               </a:rPr>
-              <a:t>reproduce LettuceDetect-base ≈ 76.07 example-level F1 — achieved 77.18 (see Results)</a:t>
+              <a:t>reproduce LettuceDetect-base ≈ 76.07 example-level F1; achieved 77.18 (see Results)</a:t>
             </a:r>
             <a:pPr indent="0" marL="0">
               <a:lnSpc>
@@ -4310,7 +4431,7 @@
                 <a:ea typeface="Calibri" pitchFamily="34" charset="-122"/>
                 <a:cs typeface="Calibri" pitchFamily="34" charset="-120"/>
               </a:rPr>
-              <a:t>F1 values are as reported by each source paper — not perfectly comparable due to differing implementations and evaluation protocols.</a:t>
+              <a:t>F1 values are as reported by each source paper, not perfectly comparable due to differing implementations and evaluation protocols.</a:t>
             </a:r>
             <a:endParaRPr lang="en-US" sz="1300" dirty="0"/>
           </a:p>
@@ -4349,7 +4470,7 @@
                 <a:ea typeface="Calibri" pitchFamily="34" charset="-122"/>
                 <a:cs typeface="Calibri" pitchFamily="34" charset="-120"/>
               </a:rPr>
-              <a:t>LettuceDetect — Literature Survey</a:t>
+              <a:t>LettuceDetect: Literature Survey</a:t>
             </a:r>
             <a:endParaRPr lang="en-US" sz="900" dirty="0"/>
           </a:p>
@@ -4516,6 +4637,10 @@
           </a:solidFill>
           <a:ln/>
         </p:spPr>
+        <p:txBody>
+          <a:bodyPr/>
+          <a:p/>
+        </p:txBody>
       </p:sp>
       <p:pic>
         <p:nvPicPr>
@@ -4574,6 +4699,10 @@
             </a:outerShdw>
           </a:effectLst>
         </p:spPr>
+        <p:txBody>
+          <a:bodyPr/>
+          <a:p/>
+        </p:txBody>
       </p:sp>
       <p:sp>
         <p:nvSpPr>
@@ -4594,6 +4723,10 @@
           </a:solidFill>
           <a:ln/>
         </p:spPr>
+        <p:txBody>
+          <a:bodyPr/>
+          <a:p/>
+        </p:txBody>
       </p:sp>
       <p:pic>
         <p:nvPicPr>
@@ -4863,6 +4996,10 @@
             </a:outerShdw>
           </a:effectLst>
         </p:spPr>
+        <p:txBody>
+          <a:bodyPr/>
+          <a:p/>
+        </p:txBody>
       </p:sp>
       <p:sp>
         <p:nvSpPr>
@@ -4883,6 +5020,10 @@
           </a:solidFill>
           <a:ln/>
         </p:spPr>
+        <p:txBody>
+          <a:bodyPr/>
+          <a:p/>
+        </p:txBody>
       </p:sp>
       <p:pic>
         <p:nvPicPr>
@@ -4984,7 +5125,7 @@
                 <a:ea typeface="Calibri" pitchFamily="34" charset="-122"/>
                 <a:cs typeface="Calibri" pitchFamily="34" charset="-120"/>
               </a:rPr>
-              <a:t>English-only — stated explicitly in the paper’s own limitations</a:t>
+              <a:t>English-only: stated explicitly in the paper’s own limitations</a:t>
             </a:r>
             <a:endParaRPr lang="en-US" sz="1300" dirty="0"/>
           </a:p>
@@ -5027,7 +5168,7 @@
                 <a:ea typeface="Calibri" pitchFamily="34" charset="-122"/>
                 <a:cs typeface="Calibri" pitchFamily="34" charset="-120"/>
               </a:rPr>
-              <a:t>Text-only signal — never examines the generator’s internal attention</a:t>
+              <a:t>Text-only signal: never examines the generator’s internal attention</a:t>
             </a:r>
             <a:endParaRPr lang="en-US" sz="1300" dirty="0"/>
           </a:p>
@@ -5113,7 +5254,7 @@
                 <a:ea typeface="Calibri" pitchFamily="34" charset="-122"/>
                 <a:cs typeface="Calibri" pitchFamily="34" charset="-120"/>
               </a:rPr>
-              <a:t>No calibration — a fixed 0.5 threshold treats all flags identically</a:t>
+              <a:t>No calibration: a fixed 0.5 threshold treats all flags identically</a:t>
             </a:r>
             <a:endParaRPr lang="en-US" sz="1300" dirty="0"/>
           </a:p>
@@ -5156,7 +5297,7 @@
                 <a:ea typeface="Calibri" pitchFamily="34" charset="-122"/>
                 <a:cs typeface="Calibri" pitchFamily="34" charset="-120"/>
               </a:rPr>
-              <a:t>Untested generalization — may perform close to random out-of-distribution</a:t>
+              <a:t>Untested generalization: may perform close to random out-of-distribution</a:t>
             </a:r>
             <a:endParaRPr lang="en-US" sz="1300" dirty="0"/>
           </a:p>
@@ -5195,7 +5336,7 @@
                 <a:ea typeface="Calibri" pitchFamily="34" charset="-122"/>
                 <a:cs typeface="Calibri" pitchFamily="34" charset="-120"/>
               </a:rPr>
-              <a:t>LettuceDetect — Literature Survey</a:t>
+              <a:t>LettuceDetect: Literature Survey</a:t>
             </a:r>
             <a:endParaRPr lang="en-US" sz="900" dirty="0"/>
           </a:p>
@@ -6671,7 +6812,7 @@
                 </a:solidFill>
                 <a:latin typeface="Calibri"/>
               </a:rPr>
-              <a:t>every script above was written from scratch and verified against real RAGTruth data — the trickiest step (label alignment) was checked against the official reference implementation before being trusted at scale.</a:t>
+              <a:t>every script above was written from scratch and verified against real RAGTruth data. The trickiest step (label alignment) was checked against the official reference implementation before being trusted at scale.</a:t>
             </a:r>
           </a:p>
         </p:txBody>
@@ -6706,7 +6847,7 @@
                 </a:solidFill>
                 <a:latin typeface="Calibri"/>
               </a:rPr>
-              <a:t>LettuceDetect — Literature Survey</a:t>
+              <a:t>LettuceDetect: Literature Survey</a:t>
             </a:r>
           </a:p>
         </p:txBody>
@@ -7970,7 +8111,7 @@
                 </a:solidFill>
                 <a:latin typeface="Calibri"/>
               </a:rPr>
-              <a:t> — exactly the class of hardware adaptation the project brief calls defensible, provided it's disclosed.</a:t>
+              <a:t>: exactly the class of hardware adaptation the project brief calls defensible, provided it's disclosed.</a:t>
             </a:r>
           </a:p>
         </p:txBody>
@@ -8005,7 +8146,7 @@
                 </a:solidFill>
                 <a:latin typeface="Calibri"/>
               </a:rPr>
-              <a:t>LettuceDetect — Literature Survey</a:t>
+              <a:t>LettuceDetect: Literature Survey</a:t>
             </a:r>
           </a:p>
         </p:txBody>
@@ -8306,7 +8447,7 @@
                 </a:solidFill>
                 <a:latin typeface="Calibri"/>
               </a:rPr>
-              <a:t> — an independently written reimplementation, not the authors' pip package, matching their published headline number.</a:t>
+              <a:t>: an independently written reimplementation, not the authors' pip package, matching their published headline number.</a:t>
             </a:r>
           </a:p>
         </p:txBody>
@@ -8341,7 +8482,7 @@
                 </a:solidFill>
                 <a:latin typeface="Calibri"/>
               </a:rPr>
-              <a:t>LettuceDetect — Literature Survey</a:t>
+              <a:t>LettuceDetect: Literature Survey</a:t>
             </a:r>
           </a:p>
         </p:txBody>
@@ -8642,7 +8783,7 @@
                 </a:solidFill>
                 <a:latin typeface="Calibri"/>
               </a:rPr>
-              <a:t>The original paper reports the same pattern — reproducing this qualitative weakness is stronger evidence of a faithful reimplementation than the aggregate score alone.</a:t>
+              <a:t>The original paper reports the same pattern, and reproducing this qualitative weakness is stronger evidence of a faithful reimplementation than the aggregate score alone.</a:t>
             </a:r>
           </a:p>
         </p:txBody>
@@ -8677,7 +8818,7 @@
                 </a:solidFill>
                 <a:latin typeface="Calibri"/>
               </a:rPr>
-              <a:t>LettuceDetect — Literature Survey</a:t>
+              <a:t>LettuceDetect: Literature Survey</a:t>
             </a:r>
           </a:p>
         </p:txBody>
@@ -8921,27 +9062,27 @@
                 </a:solidFill>
                 <a:latin typeface="Calibri"/>
               </a:rPr>
-              <a:t>Held-out, honest result</a:t>
-            </a:r>
-          </a:p>
-        </p:txBody>
-      </p:sp>
-      <p:sp>
-        <p:nvSpPr>
-          <p:cNvPr id="8" name="Rectangle 7"/>
-          <p:cNvSpPr/>
-          <p:nvPr/>
-        </p:nvSpPr>
-        <p:spPr>
-          <a:xfrm>
-            <a:off x="7909560" y="1965960"/>
-            <a:ext cx="3520440" cy="1188720"/>
+              <a:t>Held-out result, global vs. per-task</a:t>
+            </a:r>
+          </a:p>
+        </p:txBody>
+      </p:sp>
+      <p:sp>
+        <p:nvSpPr>
+          <p:cNvPr id="17" name="Rectangle 16"/>
+          <p:cNvSpPr/>
+          <p:nvPr/>
+        </p:nvSpPr>
+        <p:spPr>
+          <a:xfrm>
+            <a:off x="548640" y="5577840"/>
+            <a:ext cx="11064240" cy="731520"/>
           </a:xfrm>
           <a:prstGeom prst="rect">
             <a:avLst/>
           </a:prstGeom>
           <a:solidFill>
-            <a:srgbClr val="EEF6F5"/>
+            <a:srgbClr val="0A3A3F"/>
           </a:solidFill>
           <a:ln>
             <a:noFill/>
@@ -8972,361 +9113,6 @@
       </p:sp>
       <p:sp>
         <p:nvSpPr>
-          <p:cNvPr id="9" name="TextBox 8"/>
-          <p:cNvSpPr txBox="1"/>
-          <p:nvPr/>
-        </p:nvSpPr>
-        <p:spPr>
-          <a:xfrm>
-            <a:off x="8138160" y="2103120"/>
-            <a:ext cx="3063240" cy="320040"/>
-          </a:xfrm>
-          <a:prstGeom prst="rect">
-            <a:avLst/>
-          </a:prstGeom>
-          <a:noFill/>
-        </p:spPr>
-        <p:txBody>
-          <a:bodyPr wrap="square" lIns="0" rIns="0" tIns="0" bIns="0" anchor="ctr">
-            <a:spAutoFit/>
-          </a:bodyPr>
-          <a:lstStyle/>
-          <a:p>
-            <a:pPr algn="l"/>
-            <a:r>
-              <a:rPr sz="1100" b="1">
-                <a:solidFill>
-                  <a:srgbClr val="5B6B6B"/>
-                </a:solidFill>
-                <a:latin typeface="Calibri"/>
-              </a:rPr>
-              <a:t>Example F1</a:t>
-            </a:r>
-          </a:p>
-        </p:txBody>
-      </p:sp>
-      <p:sp>
-        <p:nvSpPr>
-          <p:cNvPr id="10" name="TextBox 9"/>
-          <p:cNvSpPr txBox="1"/>
-          <p:nvPr/>
-        </p:nvSpPr>
-        <p:spPr>
-          <a:xfrm>
-            <a:off x="8138160" y="2377440"/>
-            <a:ext cx="3063240" cy="502920"/>
-          </a:xfrm>
-          <a:prstGeom prst="rect">
-            <a:avLst/>
-          </a:prstGeom>
-          <a:noFill/>
-        </p:spPr>
-        <p:txBody>
-          <a:bodyPr wrap="square" lIns="0" rIns="0" tIns="0" bIns="0" anchor="ctr">
-            <a:spAutoFit/>
-          </a:bodyPr>
-          <a:lstStyle/>
-          <a:p>
-            <a:pPr algn="l"/>
-            <a:r>
-              <a:rPr sz="2000" b="0">
-                <a:solidFill>
-                  <a:srgbClr val="1F2D2D"/>
-                </a:solidFill>
-                <a:latin typeface="Cambria"/>
-              </a:rPr>
-              <a:t>78.18 </a:t>
-            </a:r>
-            <a:r>
-              <a:rPr sz="2000" b="1">
-                <a:solidFill>
-                  <a:srgbClr val="028090"/>
-                </a:solidFill>
-                <a:latin typeface="Cambria"/>
-              </a:rPr>
-              <a:t>→ 78.29</a:t>
-            </a:r>
-          </a:p>
-        </p:txBody>
-      </p:sp>
-      <p:sp>
-        <p:nvSpPr>
-          <p:cNvPr id="11" name="TextBox 10"/>
-          <p:cNvSpPr txBox="1"/>
-          <p:nvPr/>
-        </p:nvSpPr>
-        <p:spPr>
-          <a:xfrm>
-            <a:off x="8138160" y="2834640"/>
-            <a:ext cx="3063240" cy="274320"/>
-          </a:xfrm>
-          <a:prstGeom prst="rect">
-            <a:avLst/>
-          </a:prstGeom>
-          <a:noFill/>
-        </p:spPr>
-        <p:txBody>
-          <a:bodyPr wrap="square" lIns="0" rIns="0" tIns="0" bIns="0" anchor="ctr">
-            <a:spAutoFit/>
-          </a:bodyPr>
-          <a:lstStyle/>
-          <a:p>
-            <a:pPr algn="l"/>
-            <a:r>
-              <a:rPr sz="1050" b="0">
-                <a:solidFill>
-                  <a:srgbClr val="5B6B6B"/>
-                </a:solidFill>
-                <a:latin typeface="Calibri"/>
-              </a:rPr>
-              <a:t>+0.11, indistinguishable from noise</a:t>
-            </a:r>
-          </a:p>
-        </p:txBody>
-      </p:sp>
-      <p:sp>
-        <p:nvSpPr>
-          <p:cNvPr id="12" name="Rectangle 11"/>
-          <p:cNvSpPr/>
-          <p:nvPr/>
-        </p:nvSpPr>
-        <p:spPr>
-          <a:xfrm>
-            <a:off x="7909560" y="3291840"/>
-            <a:ext cx="3520440" cy="1188720"/>
-          </a:xfrm>
-          <a:prstGeom prst="rect">
-            <a:avLst/>
-          </a:prstGeom>
-          <a:solidFill>
-            <a:srgbClr val="EEF6F5"/>
-          </a:solidFill>
-          <a:ln>
-            <a:noFill/>
-          </a:ln>
-          <a:effectLst/>
-        </p:spPr>
-        <p:style>
-          <a:lnRef idx="1">
-            <a:schemeClr val="accent1"/>
-          </a:lnRef>
-          <a:fillRef idx="3">
-            <a:schemeClr val="accent1"/>
-          </a:fillRef>
-          <a:effectRef idx="2">
-            <a:schemeClr val="accent1"/>
-          </a:effectRef>
-          <a:fontRef idx="minor">
-            <a:schemeClr val="lt1"/>
-          </a:fontRef>
-        </p:style>
-        <p:txBody>
-          <a:bodyPr rtlCol="0" anchor="ctr"/>
-          <a:lstStyle/>
-          <a:p>
-            <a:pPr algn="ctr"/>
-          </a:p>
-        </p:txBody>
-      </p:sp>
-      <p:sp>
-        <p:nvSpPr>
-          <p:cNvPr id="13" name="TextBox 12"/>
-          <p:cNvSpPr txBox="1"/>
-          <p:nvPr/>
-        </p:nvSpPr>
-        <p:spPr>
-          <a:xfrm>
-            <a:off x="8138160" y="3429000"/>
-            <a:ext cx="3063240" cy="320040"/>
-          </a:xfrm>
-          <a:prstGeom prst="rect">
-            <a:avLst/>
-          </a:prstGeom>
-          <a:noFill/>
-        </p:spPr>
-        <p:txBody>
-          <a:bodyPr wrap="square" lIns="0" rIns="0" tIns="0" bIns="0" anchor="ctr">
-            <a:spAutoFit/>
-          </a:bodyPr>
-          <a:lstStyle/>
-          <a:p>
-            <a:pPr algn="l"/>
-            <a:r>
-              <a:rPr sz="1100" b="1">
-                <a:solidFill>
-                  <a:srgbClr val="5B6B6B"/>
-                </a:solidFill>
-                <a:latin typeface="Calibri"/>
-              </a:rPr>
-              <a:t>Span F1</a:t>
-            </a:r>
-          </a:p>
-        </p:txBody>
-      </p:sp>
-      <p:sp>
-        <p:nvSpPr>
-          <p:cNvPr id="14" name="TextBox 13"/>
-          <p:cNvSpPr txBox="1"/>
-          <p:nvPr/>
-        </p:nvSpPr>
-        <p:spPr>
-          <a:xfrm>
-            <a:off x="8138160" y="3703320"/>
-            <a:ext cx="3063240" cy="502920"/>
-          </a:xfrm>
-          <a:prstGeom prst="rect">
-            <a:avLst/>
-          </a:prstGeom>
-          <a:noFill/>
-        </p:spPr>
-        <p:txBody>
-          <a:bodyPr wrap="square" lIns="0" rIns="0" tIns="0" bIns="0" anchor="ctr">
-            <a:spAutoFit/>
-          </a:bodyPr>
-          <a:lstStyle/>
-          <a:p>
-            <a:pPr algn="l"/>
-            <a:r>
-              <a:rPr sz="2000" b="0">
-                <a:solidFill>
-                  <a:srgbClr val="1F2D2D"/>
-                </a:solidFill>
-                <a:latin typeface="Cambria"/>
-              </a:rPr>
-              <a:t>64.2 </a:t>
-            </a:r>
-            <a:r>
-              <a:rPr sz="2000" b="1">
-                <a:solidFill>
-                  <a:srgbClr val="02C39A"/>
-                </a:solidFill>
-                <a:latin typeface="Cambria"/>
-              </a:rPr>
-              <a:t>→ 66.6</a:t>
-            </a:r>
-          </a:p>
-        </p:txBody>
-      </p:sp>
-      <p:sp>
-        <p:nvSpPr>
-          <p:cNvPr id="15" name="TextBox 14"/>
-          <p:cNvSpPr txBox="1"/>
-          <p:nvPr/>
-        </p:nvSpPr>
-        <p:spPr>
-          <a:xfrm>
-            <a:off x="8138160" y="4160520"/>
-            <a:ext cx="3063240" cy="274320"/>
-          </a:xfrm>
-          <a:prstGeom prst="rect">
-            <a:avLst/>
-          </a:prstGeom>
-          <a:noFill/>
-        </p:spPr>
-        <p:txBody>
-          <a:bodyPr wrap="square" lIns="0" rIns="0" tIns="0" bIns="0" anchor="ctr">
-            <a:spAutoFit/>
-          </a:bodyPr>
-          <a:lstStyle/>
-          <a:p>
-            <a:pPr algn="l"/>
-            <a:r>
-              <a:rPr sz="1050" b="0">
-                <a:solidFill>
-                  <a:srgbClr val="5B6B6B"/>
-                </a:solidFill>
-                <a:latin typeface="Calibri"/>
-              </a:rPr>
-              <a:t>real gain: filters spurious 1-token spans</a:t>
-            </a:r>
-          </a:p>
-        </p:txBody>
-      </p:sp>
-      <p:sp>
-        <p:nvSpPr>
-          <p:cNvPr id="16" name="TextBox 15"/>
-          <p:cNvSpPr txBox="1"/>
-          <p:nvPr/>
-        </p:nvSpPr>
-        <p:spPr>
-          <a:xfrm>
-            <a:off x="7909560" y="4663440"/>
-            <a:ext cx="3520440" cy="640080"/>
-          </a:xfrm>
-          <a:prstGeom prst="rect">
-            <a:avLst/>
-          </a:prstGeom>
-          <a:noFill/>
-        </p:spPr>
-        <p:txBody>
-          <a:bodyPr wrap="square" lIns="0" rIns="0" tIns="0" bIns="0" anchor="ctr">
-            <a:spAutoFit/>
-          </a:bodyPr>
-          <a:lstStyle/>
-          <a:p>
-            <a:pPr algn="l">
-              <a:lnSpc>
-                <a:spcPct val="115000"/>
-              </a:lnSpc>
-            </a:pPr>
-            <a:r>
-              <a:rPr sz="1100" b="0">
-                <a:solidFill>
-                  <a:srgbClr val="5B6B6B"/>
-                </a:solidFill>
-                <a:latin typeface="Calibri"/>
-              </a:rPr>
-              <a:t>Tuned on one source-grouped half of test, reported only on the untouched other half.</a:t>
-            </a:r>
-          </a:p>
-        </p:txBody>
-      </p:sp>
-      <p:sp>
-        <p:nvSpPr>
-          <p:cNvPr id="17" name="Rectangle 16"/>
-          <p:cNvSpPr/>
-          <p:nvPr/>
-        </p:nvSpPr>
-        <p:spPr>
-          <a:xfrm>
-            <a:off x="548640" y="5577840"/>
-            <a:ext cx="11064240" cy="731520"/>
-          </a:xfrm>
-          <a:prstGeom prst="rect">
-            <a:avLst/>
-          </a:prstGeom>
-          <a:solidFill>
-            <a:srgbClr val="0A3A3F"/>
-          </a:solidFill>
-          <a:ln>
-            <a:noFill/>
-          </a:ln>
-          <a:effectLst/>
-        </p:spPr>
-        <p:style>
-          <a:lnRef idx="1">
-            <a:schemeClr val="accent1"/>
-          </a:lnRef>
-          <a:fillRef idx="3">
-            <a:schemeClr val="accent1"/>
-          </a:fillRef>
-          <a:effectRef idx="2">
-            <a:schemeClr val="accent1"/>
-          </a:effectRef>
-          <a:fontRef idx="minor">
-            <a:schemeClr val="lt1"/>
-          </a:fontRef>
-        </p:style>
-        <p:txBody>
-          <a:bodyPr rtlCol="0" anchor="ctr"/>
-          <a:lstStyle/>
-          <a:p>
-            <a:pPr algn="ctr"/>
-          </a:p>
-        </p:txBody>
-      </p:sp>
-      <p:sp>
-        <p:nvSpPr>
           <p:cNvPr id="18" name="TextBox 17"/>
           <p:cNvSpPr txBox="1"/>
           <p:nvPr/>
@@ -9353,22 +9139,22 @@
               </a:lnSpc>
             </a:pPr>
             <a:r>
-              <a:rPr sz="1300" b="1">
+              <a:rPr b="1" sz="1300">
                 <a:solidFill>
                   <a:srgbClr val="FFFFFF"/>
                 </a:solidFill>
                 <a:latin typeface="Calibri"/>
               </a:rPr>
-              <a:t>The paper's default 0.5 was already close to optimal</a:t>
-            </a:r>
-            <a:r>
-              <a:rPr sz="1300" b="0">
+              <a:t>A single global threshold barely moves F1, but tuning it per task finds a real +4.4 gain on Summarization</a:t>
+            </a:r>
+            <a:r>
+              <a:rPr b="0" sz="1300">
                 <a:solidFill>
                   <a:srgbClr val="FFFFFF"/>
                 </a:solidFill>
                 <a:latin typeface="Calibri"/>
               </a:rPr>
-              <a:t> for example-level F1 — tuning it further is not the free win it might look like.</a:t>
+              <a:t>, our weakest task, for zero additional training.</a:t>
             </a:r>
           </a:p>
         </p:txBody>
@@ -9403,7 +9189,7 @@
                 </a:solidFill>
                 <a:latin typeface="Calibri"/>
               </a:rPr>
-              <a:t>LettuceDetect — Literature Survey</a:t>
+              <a:t>LettuceDetect: Literature Survey</a:t>
             </a:r>
           </a:p>
         </p:txBody>
@@ -9443,6 +9229,504 @@
           </a:p>
         </p:txBody>
       </p:sp>
+      <p:graphicFrame>
+        <p:nvGraphicFramePr>
+          <p:cNvPr id="21" name="Table 20"/>
+          <p:cNvGraphicFramePr>
+            <a:graphicFrameLocks noGrp="1"/>
+          </p:cNvGraphicFramePr>
+          <p:nvPr/>
+        </p:nvGraphicFramePr>
+        <p:xfrm>
+          <a:off x="7909560" y="1965960"/>
+          <a:ext cx="3520440" cy="2606040"/>
+        </p:xfrm>
+        <a:graphic>
+          <a:graphicData uri="http://schemas.openxmlformats.org/drawingml/2006/table">
+            <a:tbl>
+              <a:tblPr firstRow="1" bandRow="1">
+                <a:tableStyleId>{5C22544A-7EE6-4342-B048-85BDC9FD1C3A}</a:tableStyleId>
+              </a:tblPr>
+              <a:tblGrid>
+                <a:gridCol w="1143000"/>
+                <a:gridCol w="822960"/>
+                <a:gridCol w="822960"/>
+                <a:gridCol w="731520"/>
+              </a:tblGrid>
+              <a:tr h="521208">
+                <a:tc>
+                  <a:txBody>
+                    <a:bodyPr wrap="square"/>
+                    <a:lstStyle/>
+                    <a:p>
+                      <a:pPr algn="ctr"/>
+                      <a:r>
+                        <a:rPr sz="1050" b="1">
+                          <a:solidFill>
+                            <a:srgbClr val="FFFFFF"/>
+                          </a:solidFill>
+                          <a:latin typeface="Calibri"/>
+                        </a:rPr>
+                        <a:t>Task</a:t>
+                      </a:r>
+                    </a:p>
+                  </a:txBody>
+                  <a:tcPr marL="45720" marR="45720" marT="27432" marB="27432" anchor="ctr">
+                    <a:solidFill>
+                      <a:srgbClr val="028090"/>
+                    </a:solidFill>
+                  </a:tcPr>
+                </a:tc>
+                <a:tc>
+                  <a:txBody>
+                    <a:bodyPr wrap="square"/>
+                    <a:lstStyle/>
+                    <a:p>
+                      <a:pPr algn="ctr"/>
+                      <a:r>
+                        <a:rPr sz="1050" b="1">
+                          <a:solidFill>
+                            <a:srgbClr val="FFFFFF"/>
+                          </a:solidFill>
+                          <a:latin typeface="Calibri"/>
+                        </a:rPr>
+                        <a:t>@0.5</a:t>
+                      </a:r>
+                    </a:p>
+                  </a:txBody>
+                  <a:tcPr marL="45720" marR="45720" marT="27432" marB="27432" anchor="ctr">
+                    <a:solidFill>
+                      <a:srgbClr val="028090"/>
+                    </a:solidFill>
+                  </a:tcPr>
+                </a:tc>
+                <a:tc>
+                  <a:txBody>
+                    <a:bodyPr wrap="square"/>
+                    <a:lstStyle/>
+                    <a:p>
+                      <a:pPr algn="ctr"/>
+                      <a:r>
+                        <a:rPr sz="1050" b="1">
+                          <a:solidFill>
+                            <a:srgbClr val="FFFFFF"/>
+                          </a:solidFill>
+                          <a:latin typeface="Calibri"/>
+                        </a:rPr>
+                        <a:t>@Tuned</a:t>
+                      </a:r>
+                    </a:p>
+                  </a:txBody>
+                  <a:tcPr marL="45720" marR="45720" marT="27432" marB="27432" anchor="ctr">
+                    <a:solidFill>
+                      <a:srgbClr val="028090"/>
+                    </a:solidFill>
+                  </a:tcPr>
+                </a:tc>
+                <a:tc>
+                  <a:txBody>
+                    <a:bodyPr wrap="square"/>
+                    <a:lstStyle/>
+                    <a:p>
+                      <a:pPr algn="ctr"/>
+                      <a:r>
+                        <a:rPr sz="1050" b="1">
+                          <a:solidFill>
+                            <a:srgbClr val="FFFFFF"/>
+                          </a:solidFill>
+                          <a:latin typeface="Calibri"/>
+                        </a:rPr>
+                        <a:t>Gain</a:t>
+                      </a:r>
+                    </a:p>
+                  </a:txBody>
+                  <a:tcPr marL="45720" marR="45720" marT="27432" marB="27432" anchor="ctr">
+                    <a:solidFill>
+                      <a:srgbClr val="028090"/>
+                    </a:solidFill>
+                  </a:tcPr>
+                </a:tc>
+              </a:tr>
+              <a:tr h="521208">
+                <a:tc>
+                  <a:txBody>
+                    <a:bodyPr wrap="square"/>
+                    <a:lstStyle/>
+                    <a:p>
+                      <a:pPr algn="ctr"/>
+                      <a:r>
+                        <a:rPr sz="1100" b="1">
+                          <a:solidFill>
+                            <a:srgbClr val="1F2D2D"/>
+                          </a:solidFill>
+                          <a:latin typeface="Calibri"/>
+                        </a:rPr>
+                        <a:t>Global</a:t>
+                      </a:r>
+                    </a:p>
+                  </a:txBody>
+                  <a:tcPr marL="45720" marR="45720" marT="27432" marB="27432" anchor="ctr">
+                    <a:solidFill>
+                      <a:srgbClr val="FFFFFF"/>
+                    </a:solidFill>
+                  </a:tcPr>
+                </a:tc>
+                <a:tc>
+                  <a:txBody>
+                    <a:bodyPr wrap="square"/>
+                    <a:lstStyle/>
+                    <a:p>
+                      <a:pPr algn="ctr"/>
+                      <a:r>
+                        <a:rPr sz="1100" b="0">
+                          <a:solidFill>
+                            <a:srgbClr val="1F2D2D"/>
+                          </a:solidFill>
+                          <a:latin typeface="Calibri"/>
+                        </a:rPr>
+                        <a:t>78.2</a:t>
+                      </a:r>
+                    </a:p>
+                  </a:txBody>
+                  <a:tcPr marL="45720" marR="45720" marT="27432" marB="27432" anchor="ctr">
+                    <a:solidFill>
+                      <a:srgbClr val="FFFFFF"/>
+                    </a:solidFill>
+                  </a:tcPr>
+                </a:tc>
+                <a:tc>
+                  <a:txBody>
+                    <a:bodyPr wrap="square"/>
+                    <a:lstStyle/>
+                    <a:p>
+                      <a:pPr algn="ctr"/>
+                      <a:r>
+                        <a:rPr sz="1100" b="0">
+                          <a:solidFill>
+                            <a:srgbClr val="1F2D2D"/>
+                          </a:solidFill>
+                          <a:latin typeface="Calibri"/>
+                        </a:rPr>
+                        <a:t>78.3</a:t>
+                      </a:r>
+                    </a:p>
+                  </a:txBody>
+                  <a:tcPr marL="45720" marR="45720" marT="27432" marB="27432" anchor="ctr">
+                    <a:solidFill>
+                      <a:srgbClr val="FFFFFF"/>
+                    </a:solidFill>
+                  </a:tcPr>
+                </a:tc>
+                <a:tc>
+                  <a:txBody>
+                    <a:bodyPr wrap="square"/>
+                    <a:lstStyle/>
+                    <a:p>
+                      <a:pPr algn="ctr"/>
+                      <a:r>
+                        <a:rPr sz="1100" b="0">
+                          <a:solidFill>
+                            <a:srgbClr val="1F2D2D"/>
+                          </a:solidFill>
+                          <a:latin typeface="Calibri"/>
+                        </a:rPr>
+                        <a:t>+0.1</a:t>
+                      </a:r>
+                    </a:p>
+                  </a:txBody>
+                  <a:tcPr marL="45720" marR="45720" marT="27432" marB="27432" anchor="ctr">
+                    <a:solidFill>
+                      <a:srgbClr val="FFFFFF"/>
+                    </a:solidFill>
+                  </a:tcPr>
+                </a:tc>
+              </a:tr>
+              <a:tr h="521208">
+                <a:tc>
+                  <a:txBody>
+                    <a:bodyPr wrap="square"/>
+                    <a:lstStyle/>
+                    <a:p>
+                      <a:pPr algn="ctr"/>
+                      <a:r>
+                        <a:rPr sz="1100" b="1">
+                          <a:solidFill>
+                            <a:srgbClr val="1F2D2D"/>
+                          </a:solidFill>
+                          <a:latin typeface="Calibri"/>
+                        </a:rPr>
+                        <a:t>Summary</a:t>
+                      </a:r>
+                    </a:p>
+                  </a:txBody>
+                  <a:tcPr marL="45720" marR="45720" marT="27432" marB="27432" anchor="ctr">
+                    <a:solidFill>
+                      <a:srgbClr val="D7EFE9"/>
+                    </a:solidFill>
+                  </a:tcPr>
+                </a:tc>
+                <a:tc>
+                  <a:txBody>
+                    <a:bodyPr wrap="square"/>
+                    <a:lstStyle/>
+                    <a:p>
+                      <a:pPr algn="ctr"/>
+                      <a:r>
+                        <a:rPr sz="1100" b="1">
+                          <a:solidFill>
+                            <a:srgbClr val="1F2D2D"/>
+                          </a:solidFill>
+                          <a:latin typeface="Calibri"/>
+                        </a:rPr>
+                        <a:t>55.2</a:t>
+                      </a:r>
+                    </a:p>
+                  </a:txBody>
+                  <a:tcPr marL="45720" marR="45720" marT="27432" marB="27432" anchor="ctr">
+                    <a:solidFill>
+                      <a:srgbClr val="D7EFE9"/>
+                    </a:solidFill>
+                  </a:tcPr>
+                </a:tc>
+                <a:tc>
+                  <a:txBody>
+                    <a:bodyPr wrap="square"/>
+                    <a:lstStyle/>
+                    <a:p>
+                      <a:pPr algn="ctr"/>
+                      <a:r>
+                        <a:rPr sz="1100" b="1">
+                          <a:solidFill>
+                            <a:srgbClr val="1F2D2D"/>
+                          </a:solidFill>
+                          <a:latin typeface="Calibri"/>
+                        </a:rPr>
+                        <a:t>59.6</a:t>
+                      </a:r>
+                    </a:p>
+                  </a:txBody>
+                  <a:tcPr marL="45720" marR="45720" marT="27432" marB="27432" anchor="ctr">
+                    <a:solidFill>
+                      <a:srgbClr val="D7EFE9"/>
+                    </a:solidFill>
+                  </a:tcPr>
+                </a:tc>
+                <a:tc>
+                  <a:txBody>
+                    <a:bodyPr wrap="square"/>
+                    <a:lstStyle/>
+                    <a:p>
+                      <a:pPr algn="ctr"/>
+                      <a:r>
+                        <a:rPr sz="1100" b="1">
+                          <a:solidFill>
+                            <a:srgbClr val="028090"/>
+                          </a:solidFill>
+                          <a:latin typeface="Calibri"/>
+                        </a:rPr>
+                        <a:t>+4.4</a:t>
+                      </a:r>
+                    </a:p>
+                  </a:txBody>
+                  <a:tcPr marL="45720" marR="45720" marT="27432" marB="27432" anchor="ctr">
+                    <a:solidFill>
+                      <a:srgbClr val="D7EFE9"/>
+                    </a:solidFill>
+                  </a:tcPr>
+                </a:tc>
+              </a:tr>
+              <a:tr h="521208">
+                <a:tc>
+                  <a:txBody>
+                    <a:bodyPr wrap="square"/>
+                    <a:lstStyle/>
+                    <a:p>
+                      <a:pPr algn="ctr"/>
+                      <a:r>
+                        <a:rPr sz="1100" b="1">
+                          <a:solidFill>
+                            <a:srgbClr val="1F2D2D"/>
+                          </a:solidFill>
+                          <a:latin typeface="Calibri"/>
+                        </a:rPr>
+                        <a:t>QA</a:t>
+                      </a:r>
+                    </a:p>
+                  </a:txBody>
+                  <a:tcPr marL="45720" marR="45720" marT="27432" marB="27432" anchor="ctr">
+                    <a:solidFill>
+                      <a:srgbClr val="FFFFFF"/>
+                    </a:solidFill>
+                  </a:tcPr>
+                </a:tc>
+                <a:tc>
+                  <a:txBody>
+                    <a:bodyPr wrap="square"/>
+                    <a:lstStyle/>
+                    <a:p>
+                      <a:pPr algn="ctr"/>
+                      <a:r>
+                        <a:rPr sz="1100" b="0">
+                          <a:solidFill>
+                            <a:srgbClr val="1F2D2D"/>
+                          </a:solidFill>
+                          <a:latin typeface="Calibri"/>
+                        </a:rPr>
+                        <a:t>63.7</a:t>
+                      </a:r>
+                    </a:p>
+                  </a:txBody>
+                  <a:tcPr marL="45720" marR="45720" marT="27432" marB="27432" anchor="ctr">
+                    <a:solidFill>
+                      <a:srgbClr val="FFFFFF"/>
+                    </a:solidFill>
+                  </a:tcPr>
+                </a:tc>
+                <a:tc>
+                  <a:txBody>
+                    <a:bodyPr wrap="square"/>
+                    <a:lstStyle/>
+                    <a:p>
+                      <a:pPr algn="ctr"/>
+                      <a:r>
+                        <a:rPr sz="1100" b="0">
+                          <a:solidFill>
+                            <a:srgbClr val="1F2D2D"/>
+                          </a:solidFill>
+                          <a:latin typeface="Calibri"/>
+                        </a:rPr>
+                        <a:t>65.4</a:t>
+                      </a:r>
+                    </a:p>
+                  </a:txBody>
+                  <a:tcPr marL="45720" marR="45720" marT="27432" marB="27432" anchor="ctr">
+                    <a:solidFill>
+                      <a:srgbClr val="FFFFFF"/>
+                    </a:solidFill>
+                  </a:tcPr>
+                </a:tc>
+                <a:tc>
+                  <a:txBody>
+                    <a:bodyPr wrap="square"/>
+                    <a:lstStyle/>
+                    <a:p>
+                      <a:pPr algn="ctr"/>
+                      <a:r>
+                        <a:rPr sz="1100" b="0">
+                          <a:solidFill>
+                            <a:srgbClr val="1F2D2D"/>
+                          </a:solidFill>
+                          <a:latin typeface="Calibri"/>
+                        </a:rPr>
+                        <a:t>+1.7</a:t>
+                      </a:r>
+                    </a:p>
+                  </a:txBody>
+                  <a:tcPr marL="45720" marR="45720" marT="27432" marB="27432" anchor="ctr">
+                    <a:solidFill>
+                      <a:srgbClr val="FFFFFF"/>
+                    </a:solidFill>
+                  </a:tcPr>
+                </a:tc>
+              </a:tr>
+              <a:tr h="521208">
+                <a:tc>
+                  <a:txBody>
+                    <a:bodyPr wrap="square"/>
+                    <a:lstStyle/>
+                    <a:p>
+                      <a:pPr algn="ctr"/>
+                      <a:r>
+                        <a:rPr sz="1100" b="1">
+                          <a:solidFill>
+                            <a:srgbClr val="1F2D2D"/>
+                          </a:solidFill>
+                          <a:latin typeface="Calibri"/>
+                        </a:rPr>
+                        <a:t>Data2txt</a:t>
+                      </a:r>
+                    </a:p>
+                  </a:txBody>
+                  <a:tcPr marL="45720" marR="45720" marT="27432" marB="27432" anchor="ctr">
+                    <a:solidFill>
+                      <a:srgbClr val="FFFFFF"/>
+                    </a:solidFill>
+                  </a:tcPr>
+                </a:tc>
+                <a:tc>
+                  <a:txBody>
+                    <a:bodyPr wrap="square"/>
+                    <a:lstStyle/>
+                    <a:p>
+                      <a:pPr algn="ctr"/>
+                      <a:r>
+                        <a:rPr sz="1100" b="0">
+                          <a:solidFill>
+                            <a:srgbClr val="1F2D2D"/>
+                          </a:solidFill>
+                          <a:latin typeface="Calibri"/>
+                        </a:rPr>
+                        <a:t>86.9</a:t>
+                      </a:r>
+                    </a:p>
+                  </a:txBody>
+                  <a:tcPr marL="45720" marR="45720" marT="27432" marB="27432" anchor="ctr">
+                    <a:solidFill>
+                      <a:srgbClr val="FFFFFF"/>
+                    </a:solidFill>
+                  </a:tcPr>
+                </a:tc>
+                <a:tc>
+                  <a:txBody>
+                    <a:bodyPr wrap="square"/>
+                    <a:lstStyle/>
+                    <a:p>
+                      <a:pPr algn="ctr"/>
+                      <a:r>
+                        <a:rPr sz="1100" b="0">
+                          <a:solidFill>
+                            <a:srgbClr val="1F2D2D"/>
+                          </a:solidFill>
+                          <a:latin typeface="Calibri"/>
+                        </a:rPr>
+                        <a:t>87.1</a:t>
+                      </a:r>
+                    </a:p>
+                  </a:txBody>
+                  <a:tcPr marL="45720" marR="45720" marT="27432" marB="27432" anchor="ctr">
+                    <a:solidFill>
+                      <a:srgbClr val="FFFFFF"/>
+                    </a:solidFill>
+                  </a:tcPr>
+                </a:tc>
+                <a:tc>
+                  <a:txBody>
+                    <a:bodyPr wrap="square"/>
+                    <a:lstStyle/>
+                    <a:p>
+                      <a:pPr algn="ctr"/>
+                      <a:r>
+                        <a:rPr sz="1100" b="0">
+                          <a:solidFill>
+                            <a:srgbClr val="1F2D2D"/>
+                          </a:solidFill>
+                          <a:latin typeface="Calibri"/>
+                        </a:rPr>
+                        <a:t>+0.2</a:t>
+                      </a:r>
+                    </a:p>
+                  </a:txBody>
+                  <a:tcPr marL="45720" marR="45720" marT="27432" marB="27432" anchor="ctr">
+                    <a:solidFill>
+                      <a:srgbClr val="FFFFFF"/>
+                    </a:solidFill>
+                  </a:tcPr>
+                </a:tc>
+              </a:tr>
+            </a:tbl>
+          </a:graphicData>
+        </a:graphic>
+      </p:graphicFrame>
     </p:spTree>
   </p:cSld>
   <p:clrMapOvr>
@@ -10066,7 +10350,25 @@
                 </a:solidFill>
                 <a:latin typeface="Calibri"/>
               </a:rPr>
-              <a:t>Threshold tuning gave less than expected — still worth reporting</a:t>
+              <a:t>Per-task threshold tuning found a real +4.4 F1 gain on Summary</a:t>
+            </a:r>
+          </a:p>
+          <a:p>
+            <a:pPr marL="182880" indent="-182880">
+              <a:spcAft>
+                <a:spcPts val="1000"/>
+              </a:spcAft>
+              <a:buFont typeface="Calibri"/>
+              <a:buChar char="•"/>
+            </a:pPr>
+            <a:r>
+              <a:rPr sz="1200" b="0">
+                <a:solidFill>
+                  <a:srgbClr val="1F2D2D"/>
+                </a:solidFill>
+                <a:latin typeface="Calibri"/>
+              </a:rPr>
+              <a:t>Planned: class-weighted retraining, targeting Summary's 3% token sparsity</a:t>
             </a:r>
           </a:p>
         </p:txBody>
@@ -10193,7 +10495,7 @@
                 </a:solidFill>
                 <a:latin typeface="Calibri"/>
               </a:rPr>
-              <a:t>LettuceDetect — Literature Survey</a:t>
+              <a:t>LettuceDetect: Literature Survey</a:t>
             </a:r>
           </a:p>
         </p:txBody>
@@ -10468,7 +10770,7 @@
                 <a:ea typeface="Calibri" pitchFamily="34" charset="-122"/>
                 <a:cs typeface="Calibri" pitchFamily="34" charset="-120"/>
               </a:rPr>
-              <a:t>we considered training on PsiloQA and reporting it as new — but PsiloQA’s own Table 4 already does exactly that, using LettuceDetect itself as one of the tested models.</a:t>
+              <a:t>we considered training on PsiloQA and reporting it as new, but PsiloQA’s own Table 4 already does exactly that, using LettuceDetect itself as one of the tested models.</a:t>
             </a:r>
             <a:endParaRPr lang="en-US" sz="1300" dirty="0"/>
           </a:p>
@@ -10860,7 +11162,7 @@
                 <a:ea typeface="Calibri" pitchFamily="34" charset="-122"/>
                 <a:cs typeface="Calibri" pitchFamily="34" charset="-120"/>
               </a:rPr>
-              <a:t>The paper only ever pits the two datasets against each other — never trains on both together.</a:t>
+              <a:t>The paper only ever pits the two datasets against each other, and never trains on both together.</a:t>
             </a:r>
             <a:endParaRPr lang="en-US" sz="1050" dirty="0"/>
           </a:p>
@@ -11265,7 +11567,7 @@
                 <a:ea typeface="Cambria" pitchFamily="34" charset="-122"/>
                 <a:cs typeface="Cambria" pitchFamily="34" charset="-120"/>
               </a:rPr>
-              <a:t>Does training LettuceDetect on combined RAGTruth + PsiloQA data reduce the cross-dataset generalization gap compared with training on either dataset alone — this is yet to be experimentally tested.</a:t>
+              <a:t>Does training LettuceDetect on combined RAGTruth + PsiloQA data reduce the cross-dataset generalization gap compared with training on either dataset alone? This is yet to be experimentally tested.</a:t>
             </a:r>
             <a:endParaRPr lang="en-US" sz="1400" dirty="0"/>
           </a:p>
@@ -11304,7 +11606,7 @@
                 <a:ea typeface="Calibri" pitchFamily="34" charset="-122"/>
                 <a:cs typeface="Calibri" pitchFamily="34" charset="-120"/>
               </a:rPr>
-              <a:t>LettuceDetect — Literature Survey</a:t>
+              <a:t>LettuceDetect: Literature Survey</a:t>
             </a:r>
             <a:endParaRPr lang="en-US" sz="900" dirty="0"/>
           </a:p>
@@ -12767,7 +13069,7 @@
                 <a:ea typeface="Calibri" pitchFamily="34" charset="-122"/>
                 <a:cs typeface="Calibri" pitchFamily="34" charset="-120"/>
               </a:rPr>
-              <a:t>LettuceDetect — Literature Survey</a:t>
+              <a:t>LettuceDetect: Literature Survey</a:t>
             </a:r>
             <a:endParaRPr lang="en-US" sz="900" dirty="0"/>
           </a:p>
@@ -12934,6 +13236,10 @@
           </a:solidFill>
           <a:ln/>
         </p:spPr>
+        <p:txBody>
+          <a:bodyPr/>
+          <a:p/>
+        </p:txBody>
       </p:sp>
       <p:pic>
         <p:nvPicPr>
@@ -12987,6 +13293,10 @@
             </a:outerShdw>
           </a:effectLst>
         </p:spPr>
+        <p:txBody>
+          <a:bodyPr/>
+          <a:p/>
+        </p:txBody>
       </p:sp>
       <p:sp>
         <p:nvSpPr>
@@ -13063,6 +13373,10 @@
           </a:solidFill>
           <a:ln/>
         </p:spPr>
+        <p:txBody>
+          <a:bodyPr/>
+          <a:p/>
+        </p:txBody>
       </p:sp>
       <p:sp>
         <p:nvSpPr>
@@ -13092,6 +13406,10 @@
             </a:outerShdw>
           </a:effectLst>
         </p:spPr>
+        <p:txBody>
+          <a:bodyPr/>
+          <a:p/>
+        </p:txBody>
       </p:sp>
       <p:sp>
         <p:nvSpPr>
@@ -13151,6 +13469,10 @@
           </a:solidFill>
           <a:ln/>
         </p:spPr>
+        <p:txBody>
+          <a:bodyPr/>
+          <a:p/>
+        </p:txBody>
       </p:sp>
       <p:sp>
         <p:nvSpPr>
@@ -13180,6 +13502,10 @@
             </a:outerShdw>
           </a:effectLst>
         </p:spPr>
+        <p:txBody>
+          <a:bodyPr/>
+          <a:p/>
+        </p:txBody>
       </p:sp>
       <p:sp>
         <p:nvSpPr>
@@ -13239,6 +13565,10 @@
           </a:solidFill>
           <a:ln/>
         </p:spPr>
+        <p:txBody>
+          <a:bodyPr/>
+          <a:p/>
+        </p:txBody>
       </p:sp>
       <p:sp>
         <p:nvSpPr>
@@ -13268,6 +13598,10 @@
             </a:outerShdw>
           </a:effectLst>
         </p:spPr>
+        <p:txBody>
+          <a:bodyPr/>
+          <a:p/>
+        </p:txBody>
       </p:sp>
       <p:sp>
         <p:nvSpPr>
@@ -13334,6 +13668,10 @@
             <a:prstDash val="solid"/>
           </a:ln>
         </p:spPr>
+        <p:txBody>
+          <a:bodyPr/>
+          <a:p/>
+        </p:txBody>
       </p:sp>
       <p:sp>
         <p:nvSpPr>
@@ -13482,7 +13820,7 @@
                 <a:ea typeface="Calibri" pitchFamily="34" charset="-122"/>
                 <a:cs typeface="Calibri" pitchFamily="34" charset="-120"/>
               </a:rPr>
-              <a:t>Highlighted text is true, but never stated in the context — unsupported, therefore a hallucination.</a:t>
+              <a:t>Highlighted text is true, but never stated in the context: unsupported, therefore a hallucination.</a:t>
             </a:r>
             <a:endParaRPr lang="en-US" sz="1200" dirty="0"/>
           </a:p>
@@ -13509,6 +13847,10 @@
           </a:solidFill>
           <a:ln/>
         </p:spPr>
+        <p:txBody>
+          <a:bodyPr/>
+          <a:p/>
+        </p:txBody>
       </p:sp>
       <p:sp>
         <p:nvSpPr>
@@ -13563,7 +13905,7 @@
                 <a:ea typeface="Calibri" pitchFamily="34" charset="-122"/>
                 <a:cs typeface="Calibri" pitchFamily="34" charset="-120"/>
               </a:rPr>
-              <a:t>"unsupported by the given context" — not "false in the real world." This narrow definition is what makes the problem checkable by a program at all.</a:t>
+              <a:t>"unsupported by the given context," not "false in the real world." This narrow definition is what makes the problem checkable by a program at all.</a:t>
             </a:r>
             <a:endParaRPr lang="en-US" sz="1700" dirty="0"/>
           </a:p>
@@ -13602,7 +13944,7 @@
                 <a:ea typeface="Calibri" pitchFamily="34" charset="-122"/>
                 <a:cs typeface="Calibri" pitchFamily="34" charset="-120"/>
               </a:rPr>
-              <a:t>LettuceDetect — Literature Survey</a:t>
+              <a:t>LettuceDetect: Literature Survey</a:t>
             </a:r>
             <a:endParaRPr lang="en-US" sz="900" dirty="0"/>
           </a:p>
@@ -14728,7 +15070,7 @@
                 <a:ea typeface="Calibri" pitchFamily="34" charset="-122"/>
                 <a:cs typeface="Calibri" pitchFamily="34" charset="-120"/>
               </a:rPr>
-              <a:t>+ Expected Calibration Error (ECE) reported for all three configurations — the same metric HALT-RAG uses.</a:t>
+              <a:t>+ Expected Calibration Error (ECE) reported for all three configurations, the same metric HALT-RAG uses.</a:t>
             </a:r>
             <a:endParaRPr lang="en-US" sz="1250" dirty="0"/>
           </a:p>
@@ -15395,7 +15737,7 @@
                 <a:ea typeface="Calibri" pitchFamily="34" charset="-122"/>
                 <a:cs typeface="Calibri" pitchFamily="34" charset="-120"/>
               </a:rPr>
-              <a:t>LettuceDetect — Literature Survey</a:t>
+              <a:t>LettuceDetect: Literature Survey</a:t>
             </a:r>
             <a:endParaRPr lang="en-US" sz="900" dirty="0"/>
           </a:p>
@@ -17449,7 +17791,7 @@
                 <a:ea typeface="Cambria" pitchFamily="34" charset="-122"/>
                 <a:cs typeface="Cambria" pitchFamily="34" charset="-120"/>
               </a:rPr>
-              <a:t>We’re not calling their pip package — we’re building the pipeline from scratch: label alignment, model, training loop, both metrics.</a:t>
+              <a:t>We’re not calling their pip package. We’re building the pipeline from scratch: label alignment, model, training loop, both metrics.</a:t>
             </a:r>
             <a:endParaRPr lang="en-US" sz="1450" dirty="0"/>
           </a:p>
@@ -17488,7 +17830,7 @@
                 <a:ea typeface="Calibri" pitchFamily="34" charset="-122"/>
                 <a:cs typeface="Calibri" pitchFamily="34" charset="-120"/>
               </a:rPr>
-              <a:t>LettuceDetect — Literature Survey</a:t>
+              <a:t>LettuceDetect: Literature Survey</a:t>
             </a:r>
             <a:endParaRPr lang="en-US" sz="900" dirty="0"/>
           </a:p>
@@ -18142,6 +18484,10 @@
           </a:solidFill>
           <a:ln/>
         </p:spPr>
+        <p:txBody>
+          <a:bodyPr/>
+          <a:p/>
+        </p:txBody>
       </p:sp>
       <p:pic>
         <p:nvPicPr>
@@ -18200,6 +18546,10 @@
             </a:outerShdw>
           </a:effectLst>
         </p:spPr>
+        <p:txBody>
+          <a:bodyPr/>
+          <a:p/>
+        </p:txBody>
       </p:sp>
       <p:sp>
         <p:nvSpPr>
@@ -18222,6 +18572,10 @@
           </a:solidFill>
           <a:ln/>
         </p:spPr>
+        <p:txBody>
+          <a:bodyPr/>
+          <a:p/>
+        </p:txBody>
       </p:sp>
       <p:sp>
         <p:nvSpPr>
@@ -18242,6 +18596,10 @@
           </a:solidFill>
           <a:ln/>
         </p:spPr>
+        <p:txBody>
+          <a:bodyPr/>
+          <a:p/>
+        </p:txBody>
       </p:sp>
       <p:sp>
         <p:nvSpPr>
@@ -18552,6 +18910,10 @@
             </a:outerShdw>
           </a:effectLst>
         </p:spPr>
+        <p:txBody>
+          <a:bodyPr/>
+          <a:p/>
+        </p:txBody>
       </p:sp>
       <p:sp>
         <p:nvSpPr>
@@ -18574,6 +18936,10 @@
           </a:solidFill>
           <a:ln/>
         </p:spPr>
+        <p:txBody>
+          <a:bodyPr/>
+          <a:p/>
+        </p:txBody>
       </p:sp>
       <p:sp>
         <p:nvSpPr>
@@ -18594,6 +18960,10 @@
           </a:solidFill>
           <a:ln/>
         </p:spPr>
+        <p:txBody>
+          <a:bodyPr/>
+          <a:p/>
+        </p:txBody>
       </p:sp>
       <p:sp>
         <p:nvSpPr>
@@ -18932,6 +19302,10 @@
           </a:solidFill>
           <a:ln/>
         </p:spPr>
+        <p:txBody>
+          <a:bodyPr/>
+          <a:p/>
+        </p:txBody>
       </p:sp>
       <p:sp>
         <p:nvSpPr>
@@ -18966,7 +19340,7 @@
                 <a:ea typeface="Calibri" pitchFamily="34" charset="-122"/>
                 <a:cs typeface="Calibri" pitchFamily="34" charset="-120"/>
               </a:rPr>
-              <a:t>The field was stuck between accurate-and-expensive and cheap-and-blind — nobody wanted a safety check that costs more than the thing it’s checking.</a:t>
+              <a:t>The field was stuck between accurate-and-expensive and cheap-and-blind. Nobody wanted a safety check that costs more than the thing it’s checking.</a:t>
             </a:r>
             <a:endParaRPr lang="en-US" sz="1400" dirty="0"/>
           </a:p>
@@ -19005,7 +19379,7 @@
                 <a:ea typeface="Calibri" pitchFamily="34" charset="-122"/>
                 <a:cs typeface="Calibri" pitchFamily="34" charset="-120"/>
               </a:rPr>
-              <a:t>LettuceDetect — Literature Survey</a:t>
+              <a:t>LettuceDetect: Literature Survey</a:t>
             </a:r>
             <a:endParaRPr lang="en-US" sz="900" dirty="0"/>
           </a:p>
@@ -19172,6 +19546,10 @@
           </a:solidFill>
           <a:ln/>
         </p:spPr>
+        <p:txBody>
+          <a:bodyPr/>
+          <a:p/>
+        </p:txBody>
       </p:sp>
       <p:pic>
         <p:nvPicPr>
@@ -19219,6 +19597,10 @@
             <a:prstDash val="solid"/>
           </a:ln>
         </p:spPr>
+        <p:txBody>
+          <a:bodyPr/>
+          <a:p/>
+        </p:txBody>
       </p:sp>
       <p:sp>
         <p:nvSpPr>
@@ -19244,6 +19626,10 @@
             <a:prstDash val="solid"/>
           </a:ln>
         </p:spPr>
+        <p:txBody>
+          <a:bodyPr/>
+          <a:p/>
+        </p:txBody>
       </p:sp>
       <p:sp>
         <p:nvSpPr>
@@ -19327,6 +19713,10 @@
             <a:prstDash val="solid"/>
           </a:ln>
         </p:spPr>
+        <p:txBody>
+          <a:bodyPr/>
+          <a:p/>
+        </p:txBody>
       </p:sp>
       <p:sp>
         <p:nvSpPr>
@@ -19447,6 +19837,10 @@
             <a:prstDash val="solid"/>
           </a:ln>
         </p:spPr>
+        <p:txBody>
+          <a:bodyPr/>
+          <a:p/>
+        </p:txBody>
       </p:sp>
       <p:sp>
         <p:nvSpPr>
@@ -19513,6 +19907,10 @@
             <a:prstDash val="solid"/>
           </a:ln>
         </p:spPr>
+        <p:txBody>
+          <a:bodyPr/>
+          <a:p/>
+        </p:txBody>
       </p:sp>
       <p:sp>
         <p:nvSpPr>
@@ -19633,6 +20031,10 @@
             <a:prstDash val="solid"/>
           </a:ln>
         </p:spPr>
+        <p:txBody>
+          <a:bodyPr/>
+          <a:p/>
+        </p:txBody>
       </p:sp>
       <p:sp>
         <p:nvSpPr>
@@ -19716,6 +20118,10 @@
             <a:prstDash val="solid"/>
           </a:ln>
         </p:spPr>
+        <p:txBody>
+          <a:bodyPr/>
+          <a:p/>
+        </p:txBody>
       </p:sp>
       <p:sp>
         <p:nvSpPr>
@@ -19836,6 +20242,10 @@
             <a:prstDash val="solid"/>
           </a:ln>
         </p:spPr>
+        <p:txBody>
+          <a:bodyPr/>
+          <a:p/>
+        </p:txBody>
       </p:sp>
       <p:sp>
         <p:nvSpPr>
@@ -19919,6 +20329,10 @@
             <a:prstDash val="solid"/>
           </a:ln>
         </p:spPr>
+        <p:txBody>
+          <a:bodyPr/>
+          <a:p/>
+        </p:txBody>
       </p:sp>
       <p:sp>
         <p:nvSpPr>
@@ -20039,6 +20453,10 @@
             <a:prstDash val="solid"/>
           </a:ln>
         </p:spPr>
+        <p:txBody>
+          <a:bodyPr/>
+          <a:p/>
+        </p:txBody>
       </p:sp>
       <p:sp>
         <p:nvSpPr>
@@ -20122,6 +20540,10 @@
             <a:prstDash val="solid"/>
           </a:ln>
         </p:spPr>
+        <p:txBody>
+          <a:bodyPr/>
+          <a:p/>
+        </p:txBody>
       </p:sp>
       <p:sp>
         <p:nvSpPr>
@@ -20242,6 +20664,10 @@
             <a:prstDash val="solid"/>
           </a:ln>
         </p:spPr>
+        <p:txBody>
+          <a:bodyPr/>
+          <a:p/>
+        </p:txBody>
       </p:sp>
       <p:sp>
         <p:nvSpPr>
@@ -20332,6 +20758,10 @@
             </a:outerShdw>
           </a:effectLst>
         </p:spPr>
+        <p:txBody>
+          <a:bodyPr/>
+          <a:p/>
+        </p:txBody>
       </p:sp>
       <p:sp>
         <p:nvSpPr>
@@ -20452,6 +20882,10 @@
             <a:prstDash val="solid"/>
           </a:ln>
         </p:spPr>
+        <p:txBody>
+          <a:bodyPr/>
+          <a:p/>
+        </p:txBody>
       </p:sp>
       <p:sp>
         <p:nvSpPr>
@@ -20535,6 +20969,10 @@
             <a:prstDash val="solid"/>
           </a:ln>
         </p:spPr>
+        <p:txBody>
+          <a:bodyPr/>
+          <a:p/>
+        </p:txBody>
       </p:sp>
       <p:sp>
         <p:nvSpPr>
@@ -20655,6 +21093,10 @@
             <a:prstDash val="solid"/>
           </a:ln>
         </p:spPr>
+        <p:txBody>
+          <a:bodyPr/>
+          <a:p/>
+        </p:txBody>
       </p:sp>
       <p:sp>
         <p:nvSpPr>
@@ -20738,6 +21180,10 @@
             <a:prstDash val="solid"/>
           </a:ln>
         </p:spPr>
+        <p:txBody>
+          <a:bodyPr/>
+          <a:p/>
+        </p:txBody>
       </p:sp>
       <p:sp>
         <p:nvSpPr>
@@ -20858,6 +21304,10 @@
             <a:prstDash val="solid"/>
           </a:ln>
         </p:spPr>
+        <p:txBody>
+          <a:bodyPr/>
+          <a:p/>
+        </p:txBody>
       </p:sp>
       <p:sp>
         <p:nvSpPr>
@@ -20941,6 +21391,10 @@
             <a:prstDash val="solid"/>
           </a:ln>
         </p:spPr>
+        <p:txBody>
+          <a:bodyPr/>
+          <a:p/>
+        </p:txBody>
       </p:sp>
       <p:sp>
         <p:nvSpPr>
@@ -21063,6 +21517,10 @@
             <a:prstDash val="solid"/>
           </a:ln>
         </p:spPr>
+        <p:txBody>
+          <a:bodyPr/>
+          <a:p/>
+        </p:txBody>
       </p:sp>
       <p:sp>
         <p:nvSpPr>
@@ -21097,7 +21555,7 @@
                 <a:ea typeface="Calibri" pitchFamily="34" charset="-122"/>
                 <a:cs typeface="Calibri" pitchFamily="34" charset="-120"/>
               </a:rPr>
-              <a:t>Each step reacts to a specific gap in the one before it — a chain of reasoning, not a random list.</a:t>
+              <a:t>Each step reacts to a specific gap in the one before it: a chain of reasoning, not a random list.</a:t>
             </a:r>
             <a:endParaRPr lang="en-US" sz="1300" dirty="0"/>
           </a:p>
@@ -21136,7 +21594,7 @@
                 <a:ea typeface="Calibri" pitchFamily="34" charset="-122"/>
                 <a:cs typeface="Calibri" pitchFamily="34" charset="-120"/>
               </a:rPr>
-              <a:t>LettuceDetect — Literature Survey</a:t>
+              <a:t>LettuceDetect: Literature Survey</a:t>
             </a:r>
             <a:endParaRPr lang="en-US" sz="900" dirty="0"/>
           </a:p>
@@ -21303,6 +21761,10 @@
           </a:solidFill>
           <a:ln/>
         </p:spPr>
+        <p:txBody>
+          <a:bodyPr/>
+          <a:p/>
+        </p:txBody>
       </p:sp>
       <p:pic>
         <p:nvPicPr>
@@ -25195,7 +25657,7 @@
                 <a:ea typeface="Calibri" pitchFamily="34" charset="-122"/>
                 <a:cs typeface="Calibri" pitchFamily="34" charset="-120"/>
               </a:rPr>
-              <a:t>LettuceDetect — Literature Survey</a:t>
+              <a:t>LettuceDetect: Literature Survey</a:t>
             </a:r>
             <a:endParaRPr lang="en-US" sz="900" dirty="0"/>
           </a:p>
@@ -25362,6 +25824,10 @@
           </a:solidFill>
           <a:ln/>
         </p:spPr>
+        <p:txBody>
+          <a:bodyPr/>
+          <a:p/>
+        </p:txBody>
       </p:sp>
       <p:pic>
         <p:nvPicPr>
@@ -27906,6 +28372,10 @@
           </a:solidFill>
           <a:ln/>
         </p:spPr>
+        <p:txBody>
+          <a:bodyPr/>
+          <a:p/>
+        </p:txBody>
       </p:sp>
       <p:sp>
         <p:nvSpPr>
@@ -27940,7 +28410,7 @@
                 <a:ea typeface="Calibri" pitchFamily="34" charset="-122"/>
                 <a:cs typeface="Calibri" pitchFamily="34" charset="-120"/>
               </a:rPr>
-              <a:t>Our reimplementation uses RAGTruth exclusively — the only dataset here that is public, human-annotated at span level, and directly comparable to LettuceDetect’s published numbers.</a:t>
+              <a:t>Our reimplementation uses RAGTruth exclusively, the only dataset here that is public, human-annotated at span level, and directly comparable to LettuceDetect’s published numbers.</a:t>
             </a:r>
             <a:endParaRPr lang="en-US" sz="1150" dirty="0"/>
           </a:p>
@@ -27979,7 +28449,7 @@
                 <a:ea typeface="Calibri" pitchFamily="34" charset="-122"/>
                 <a:cs typeface="Calibri" pitchFamily="34" charset="-120"/>
               </a:rPr>
-              <a:t>LettuceDetect — Literature Survey</a:t>
+              <a:t>LettuceDetect: Literature Survey</a:t>
             </a:r>
             <a:endParaRPr lang="en-US" sz="900" dirty="0"/>
           </a:p>
@@ -28146,6 +28616,10 @@
           </a:solidFill>
           <a:ln/>
         </p:spPr>
+        <p:txBody>
+          <a:bodyPr/>
+          <a:p/>
+        </p:txBody>
       </p:sp>
       <p:pic>
         <p:nvPicPr>
@@ -28199,6 +28673,10 @@
             </a:outerShdw>
           </a:effectLst>
         </p:spPr>
+        <p:txBody>
+          <a:bodyPr/>
+          <a:p/>
+        </p:txBody>
       </p:sp>
       <p:sp>
         <p:nvSpPr>
@@ -28292,6 +28770,10 @@
           </a:solidFill>
           <a:ln/>
         </p:spPr>
+        <p:txBody>
+          <a:bodyPr/>
+          <a:p/>
+        </p:txBody>
       </p:sp>
       <p:sp>
         <p:nvSpPr>
@@ -28321,6 +28803,10 @@
             </a:outerShdw>
           </a:effectLst>
         </p:spPr>
+        <p:txBody>
+          <a:bodyPr/>
+          <a:p/>
+        </p:txBody>
       </p:sp>
       <p:sp>
         <p:nvSpPr>
@@ -28397,6 +28883,10 @@
           </a:solidFill>
           <a:ln/>
         </p:spPr>
+        <p:txBody>
+          <a:bodyPr/>
+          <a:p/>
+        </p:txBody>
       </p:sp>
       <p:sp>
         <p:nvSpPr>
@@ -28426,6 +28916,10 @@
             </a:outerShdw>
           </a:effectLst>
         </p:spPr>
+        <p:txBody>
+          <a:bodyPr/>
+          <a:p/>
+        </p:txBody>
       </p:sp>
       <p:sp>
         <p:nvSpPr>
@@ -28502,6 +28996,10 @@
           </a:solidFill>
           <a:ln/>
         </p:spPr>
+        <p:txBody>
+          <a:bodyPr/>
+          <a:p/>
+        </p:txBody>
       </p:sp>
       <p:sp>
         <p:nvSpPr>
@@ -28531,6 +29029,10 @@
             </a:outerShdw>
           </a:effectLst>
         </p:spPr>
+        <p:txBody>
+          <a:bodyPr/>
+          <a:p/>
+        </p:txBody>
       </p:sp>
       <p:sp>
         <p:nvSpPr>
@@ -28607,6 +29109,10 @@
           </a:solidFill>
           <a:ln/>
         </p:spPr>
+        <p:txBody>
+          <a:bodyPr/>
+          <a:p/>
+        </p:txBody>
       </p:sp>
       <p:sp>
         <p:nvSpPr>
@@ -28636,6 +29142,10 @@
             </a:outerShdw>
           </a:effectLst>
         </p:spPr>
+        <p:txBody>
+          <a:bodyPr/>
+          <a:p/>
+        </p:txBody>
       </p:sp>
       <p:sp>
         <p:nvSpPr>
@@ -28712,6 +29222,10 @@
           </a:solidFill>
           <a:ln/>
         </p:spPr>
+        <p:txBody>
+          <a:bodyPr/>
+          <a:p/>
+        </p:txBody>
       </p:sp>
       <p:sp>
         <p:nvSpPr>
@@ -28741,6 +29255,10 @@
             </a:outerShdw>
           </a:effectLst>
         </p:spPr>
+        <p:txBody>
+          <a:bodyPr/>
+          <a:p/>
+        </p:txBody>
       </p:sp>
       <p:sp>
         <p:nvSpPr>
@@ -28885,7 +29403,7 @@
                 <a:ea typeface="Calibri" pitchFamily="34" charset="-122"/>
                 <a:cs typeface="Calibri" pitchFamily="34" charset="-120"/>
               </a:rPr>
-              <a:t> (PyTorch’s "ignore in loss" sentinel) — the model reads them, but is graded only on its predictions for answer tokens.</a:t>
+              <a:t> (PyTorch’s "ignore in loss" sentinel). The model reads them, but is graded only on its predictions for answer tokens.</a:t>
             </a:r>
             <a:endParaRPr lang="en-US" sz="1400" dirty="0"/>
           </a:p>
@@ -28910,6 +29428,10 @@
           </a:solidFill>
           <a:ln/>
         </p:spPr>
+        <p:txBody>
+          <a:bodyPr/>
+          <a:p/>
+        </p:txBody>
       </p:sp>
       <p:pic>
         <p:nvPicPr>
@@ -29032,6 +29554,10 @@
           </a:solidFill>
           <a:ln/>
         </p:spPr>
+        <p:txBody>
+          <a:bodyPr/>
+          <a:p/>
+        </p:txBody>
       </p:sp>
       <p:pic>
         <p:nvPicPr>
@@ -29154,6 +29680,10 @@
           </a:solidFill>
           <a:ln/>
         </p:spPr>
+        <p:txBody>
+          <a:bodyPr/>
+          <a:p/>
+        </p:txBody>
       </p:sp>
       <p:pic>
         <p:nvPicPr>
@@ -29283,6 +29813,10 @@
             <a:prstDash val="solid"/>
           </a:ln>
         </p:spPr>
+        <p:txBody>
+          <a:bodyPr/>
+          <a:p/>
+        </p:txBody>
       </p:sp>
       <p:sp>
         <p:nvSpPr>
@@ -29317,7 +29851,7 @@
                 <a:ea typeface="Calibri" pitchFamily="34" charset="-122"/>
                 <a:cs typeface="Calibri" pitchFamily="34" charset="-120"/>
               </a:rPr>
-              <a:t>The reframe (token-level classification) wasn’t a new idea — it only became possible once a long-context encoder existed. Recognizing that timing is the paper’s real contribution.</a:t>
+              <a:t>The reframe (token-level classification) wasn’t a new idea. It only became possible once a long-context encoder existed, and recognizing that timing is the paper’s real contribution.</a:t>
             </a:r>
             <a:endParaRPr lang="en-US" sz="1300" dirty="0"/>
           </a:p>
@@ -29356,7 +29890,7 @@
                 <a:ea typeface="Calibri" pitchFamily="34" charset="-122"/>
                 <a:cs typeface="Calibri" pitchFamily="34" charset="-120"/>
               </a:rPr>
-              <a:t>LettuceDetect — Literature Survey</a:t>
+              <a:t>LettuceDetect: Literature Survey</a:t>
             </a:r>
             <a:endParaRPr lang="en-US" sz="900" dirty="0"/>
           </a:p>
@@ -29523,6 +30057,10 @@
           </a:solidFill>
           <a:ln/>
         </p:spPr>
+        <p:txBody>
+          <a:bodyPr/>
+          <a:p/>
+        </p:txBody>
       </p:sp>
       <p:pic>
         <p:nvPicPr>
@@ -29608,6 +30146,10 @@
           </a:solidFill>
           <a:ln/>
         </p:spPr>
+        <p:txBody>
+          <a:bodyPr/>
+          <a:p/>
+        </p:txBody>
       </p:sp>
       <p:sp>
         <p:nvSpPr>
@@ -29708,6 +30250,10 @@
           </a:solidFill>
           <a:ln/>
         </p:spPr>
+        <p:txBody>
+          <a:bodyPr/>
+          <a:p/>
+        </p:txBody>
       </p:sp>
       <p:sp>
         <p:nvSpPr>
@@ -29820,6 +30366,10 @@
             </a:outerShdw>
           </a:effectLst>
         </p:spPr>
+        <p:txBody>
+          <a:bodyPr/>
+          <a:p/>
+        </p:txBody>
       </p:sp>
       <p:sp>
         <p:nvSpPr>
@@ -29896,7 +30446,7 @@
                 <a:ea typeface="Calibri" pitchFamily="34" charset="-122"/>
                 <a:cs typeface="Calibri" pitchFamily="34" charset="-120"/>
               </a:rPr>
-              <a:t>Original BERT learns one position vector per slot, 1–512. Slot 513 simply doesn’t exist — a hard architectural wall.</a:t>
+              <a:t>Original BERT learns one position vector per slot, 1–512. Slot 513 simply doesn’t exist: a hard architectural wall.</a:t>
             </a:r>
             <a:endParaRPr lang="en-US" sz="1250" dirty="0"/>
           </a:p>
@@ -29935,6 +30485,10 @@
             </a:outerShdw>
           </a:effectLst>
         </p:spPr>
+        <p:txBody>
+          <a:bodyPr/>
+          <a:p/>
+        </p:txBody>
       </p:sp>
       <p:sp>
         <p:nvSpPr>
@@ -30011,7 +30565,7 @@
                 <a:ea typeface="Calibri" pitchFamily="34" charset="-122"/>
                 <a:cs typeface="Calibri" pitchFamily="34" charset="-120"/>
               </a:rPr>
-              <a:t>Rotary Position Embeddings encode position as a mathematical rotation defined for any position — extending capacity to 8,192 tokens.</a:t>
+              <a:t>Rotary Position Embeddings encode position as a mathematical rotation defined for any position, extending capacity to 8,192 tokens.</a:t>
             </a:r>
             <a:endParaRPr lang="en-US" sz="1250" dirty="0"/>
           </a:p>
@@ -30050,7 +30604,7 @@
                 <a:ea typeface="Calibri" pitchFamily="34" charset="-122"/>
                 <a:cs typeface="Calibri" pitchFamily="34" charset="-120"/>
               </a:rPr>
-              <a:t>LettuceDetect — Literature Survey</a:t>
+              <a:t>LettuceDetect: Literature Survey</a:t>
             </a:r>
             <a:endParaRPr lang="en-US" sz="900" dirty="0"/>
           </a:p>
@@ -30217,6 +30771,10 @@
           </a:solidFill>
           <a:ln/>
         </p:spPr>
+        <p:txBody>
+          <a:bodyPr/>
+          <a:p/>
+        </p:txBody>
       </p:sp>
       <p:pic>
         <p:nvPicPr>
@@ -31678,6 +32236,10 @@
             <a:prstDash val="solid"/>
           </a:ln>
         </p:spPr>
+        <p:txBody>
+          <a:bodyPr/>
+          <a:p/>
+        </p:txBody>
       </p:sp>
       <p:sp>
         <p:nvSpPr>
@@ -31786,6 +32348,10 @@
             <a:prstDash val="solid"/>
           </a:ln>
         </p:spPr>
+        <p:txBody>
+          <a:bodyPr/>
+          <a:p/>
+        </p:txBody>
       </p:sp>
       <p:sp>
         <p:nvSpPr>
@@ -31862,7 +32428,7 @@
                 <a:ea typeface="Calibri" pitchFamily="34" charset="-122"/>
                 <a:cs typeface="Calibri" pitchFamily="34" charset="-120"/>
               </a:rPr>
-              <a:t>Character-overlap matching between predicted and gold spans. No official reference implementation — each paper self-implements this, so numbers are indicative, not exactly comparable.</a:t>
+              <a:t>Character-overlap matching between predicted and gold spans. No official reference implementation exists; each paper self-implements this, so numbers are indicative, not exactly comparable.</a:t>
             </a:r>
             <a:endParaRPr lang="en-US" sz="1200" dirty="0"/>
           </a:p>
@@ -31889,6 +32455,10 @@
           </a:solidFill>
           <a:ln/>
         </p:spPr>
+        <p:txBody>
+          <a:bodyPr/>
+          <a:p/>
+        </p:txBody>
       </p:sp>
       <p:sp>
         <p:nvSpPr>
@@ -31962,7 +32532,7 @@
                 <a:ea typeface="Calibri" pitchFamily="34" charset="-122"/>
                 <a:cs typeface="Calibri" pitchFamily="34" charset="-120"/>
               </a:rPr>
-              <a:t>LettuceDetect — Literature Survey</a:t>
+              <a:t>LettuceDetect: Literature Survey</a:t>
             </a:r>
             <a:endParaRPr lang="en-US" sz="900" dirty="0"/>
           </a:p>

</xml_diff>